<commit_message>
refactor: adiciona snippet de codigo Kosaraju
</commit_message>
<xml_diff>
--- a/T2/apresentacao/apresentacao.pptx
+++ b/T2/apresentacao/apresentacao.pptx
@@ -20,6 +20,7 @@
     <p:sldId id="267" r:id="rId19"/>
     <p:sldId id="268" r:id="rId20"/>
     <p:sldId id="269" r:id="rId21"/>
+    <p:sldId id="270" r:id="rId22"/>
     <p:sldId id="259" r:id="rId8"/>
   </p:sldIdLst>
   <p:sldSz cy="5143500" cx="9144000"/>
@@ -1104,7 +1105,7 @@
           <a:lstStyle/>
           <a:p>
             <a:r>
-              <a:t>Slide 9 (~50 s). Agora um pouco de código, só o essencial. O grafo é um Digraph com listas de adjacência, uma Bag por vértice, e o método reverse gera G transposto. A fase 1 é o DepthFirstOrder, que empilha cada vértice ao terminar numa Stack. A fase 2 é este laço: percorre a pilha e, a cada vértice não marcado, dispara uma DFS que grava o id, e soma um no count. São duas DFS mais a construção de G transposto: tempo O de V mais E. Um detalhe prático: a recursão pode ter cem mil níveis, num ciclo que passa por todas as cidades, e estoura a pilha padrão da JVM. Diferente do T1, aqui não dá para trocar por BFS, porque a BFS não tem pós-ordem. Então mantivemos a DFS e rodamos numa Thread com 256 MB de pilha.</a:t>
+              <a:t>Slide 9 (~50 s). Este é o coração do código, copiado do Main.java. São três partes. Primeiro, a fase 1: uma linha só. O DepthFirstOrder roda a DFS no grafo reverso e devolve a pós-ordem reversa, ou seja, a ordem topológica de G transposto. Segundo, a fase 2: percorremos essa ordem e, toda vez que encontramos um vértice ainda não marcado, disparamos uma DFS em G e somamos um no count. Cada DFS disparada aqui é uma componente, porque ela sempre começa num sumidouro do que ainda sobrou. Terceiro, a dfs em si: marca o vértice, grava o id da componente atual e só desce para quem ainda não foi marcado. É esse if que impede a DFS de vazar para uma componente já pintada. Repare que a dfs é a mesma DFS de sempre; toda a mágica está na ordem do for.</a:t>
             </a:r>
           </a:p>
         </p:txBody>
@@ -1162,7 +1163,65 @@
           <a:lstStyle/>
           <a:p>
             <a:r>
-              <a:t>Slide 10 (~40 s). Testamos oito casos pequenos e cinco de estresse, todos corretos. Como o NO aceita qualquer par, cada resposta NO foi conferida por um verificador, que roda uma BFS a partir de a e confirma que b não é alcançado. O caso de propósito é o de dois ciclos ligados num só sentido: tratando o grafo como não direcionado daria YES, e o certo é NO. O código recebeu Accepted no CSES nos 20 testes, com pior tempo de 0,97 segundo contra limite de 1 segundo. Resumindo: o problema era conectividade forte, e a ordem topológica do grafo transposto é o que faz cada DFS marcar exatamente uma componente. Obrigado.</a:t>
+              <a:t>Slide 10 (~40 s). Por trás desse trecho estão poucas estruturas. O grafo é um Digraph com listas de adjacência, uma Bag por vértice, e o reverse gera G transposto percorrendo todas as arestas uma vez. À direita estão as duas listas do exemplo: repare que cada seta aparece invertida. A Stack guarda a pós-ordem reversa, e os vetores marked e id dizem se o vértice foi visitado e em qual componente ele está. São duas DFS mais a construção de G transposto: tempo O de V mais E. Um detalhe prático: a recursão pode ter cem mil níveis, num ciclo que passa por todas as cidades, e estoura a pilha padrão da JVM. Diferente do T1, aqui não dá para trocar por BFS, porque a BFS não tem pós-ordem. Então mantivemos a DFS e rodamos numa Thread com 256 MB de pilha.</a:t>
+            </a:r>
+          </a:p>
+        </p:txBody>
+      </p:sp>
+    </p:spTree>
+  </p:cSld>
+  <p:clrMapOvr>
+    <a:masterClrMapping/>
+  </p:clrMapOvr>
+</p:notes>
+</file>
+
+<file path=ppt/notesSlides/notesSlide14.xml><?xml version="1.0" encoding="utf-8"?>
+<p:notes xmlns:a="http://schemas.openxmlformats.org/drawingml/2006/main" xmlns:p="http://schemas.openxmlformats.org/presentationml/2006/main" xmlns:r="http://schemas.openxmlformats.org/officeDocument/2006/relationships">
+  <p:cSld>
+    <p:spTree>
+      <p:nvGrpSpPr>
+        <p:cNvPr id="1" name=""/>
+        <p:cNvGrpSpPr/>
+        <p:nvPr/>
+      </p:nvGrpSpPr>
+      <p:grpSpPr>
+        <a:xfrm>
+          <a:off x="0" y="0"/>
+          <a:ext cx="0" cy="0"/>
+          <a:chOff x="0" y="0"/>
+          <a:chExt cx="0" cy="0"/>
+        </a:xfrm>
+      </p:grpSpPr>
+      <p:sp>
+        <p:nvSpPr>
+          <p:cNvPr id="2" name="Slide Image Placeholder 1"/>
+          <p:cNvSpPr>
+            <a:spLocks noGrp="1"/>
+          </p:cNvSpPr>
+          <p:nvPr>
+            <p:ph type="sldImg" idx="2"/>
+          </p:nvPr>
+        </p:nvSpPr>
+        <p:spPr/>
+      </p:sp>
+      <p:sp>
+        <p:nvSpPr>
+          <p:cNvPr id="3" name="Notes Placeholder 2"/>
+          <p:cNvSpPr>
+            <a:spLocks noGrp="1"/>
+          </p:cNvSpPr>
+          <p:nvPr>
+            <p:ph type="body" idx="1"/>
+          </p:nvPr>
+        </p:nvSpPr>
+        <p:spPr/>
+        <p:txBody>
+          <a:bodyPr/>
+          <a:lstStyle/>
+          <a:p>
+            <a:r>
+              <a:t>Slide 11 (~40 s). Testamos oito casos pequenos e cinco de estresse, todos corretos. Como o NO aceita qualquer par, cada resposta NO foi conferida por um verificador, que roda uma BFS a partir de a e confirma que b não é alcançado. O caso de propósito é o de dois ciclos ligados num só sentido: tratando o grafo como não direcionado daria YES, e o certo é NO. O código recebeu Accepted no CSES nos 20 testes, com pior tempo de 0,97 segundo contra limite de 1 segundo. Resumindo: o problema era conectividade forte, e a ordem topológica do grafo transposto é o que faz cada DFS marcar exatamente uma componente. Obrigado.</a:t>
             </a:r>
           </a:p>
         </p:txBody>
@@ -12057,7 +12116,7 @@
                 </a:solidFill>
                 <a:latin typeface="Arial"/>
               </a:rPr>
-              <a:t>Estruturas e custo</a:t>
+              <a:t>Kosaraju no código</a:t>
             </a:r>
           </a:p>
           <a:p>
@@ -12069,156 +12128,21 @@
                 </a:solidFill>
                 <a:latin typeface="Arial"/>
               </a:rPr>
-              <a:t>O que o código usa (algs4)</a:t>
+              <a:t>O trecho principal (algs4.KosarajuSharirSCC)</a:t>
             </a:r>
           </a:p>
         </p:txBody>
       </p:sp>
       <p:sp>
         <p:nvSpPr>
-          <p:cNvPr id="3" name="Texto"/>
-          <p:cNvSpPr txBox="1"/>
-          <p:nvPr/>
-        </p:nvSpPr>
-        <p:spPr>
-          <a:xfrm>
-            <a:off x="731520" y="1554480"/>
-            <a:ext cx="3566160" cy="2743200"/>
-          </a:xfrm>
-          <a:prstGeom prst="rect">
-            <a:avLst/>
-          </a:prstGeom>
-          <a:noFill/>
-        </p:spPr>
-        <p:txBody>
-          <a:bodyPr wrap="square" lIns="0" rIns="0" tIns="0" bIns="0" anchor="t">
-            <a:spAutoFit/>
-          </a:bodyPr>
-          <a:lstStyle/>
-          <a:p>
-            <a:pPr algn="l">
-              <a:lnSpc>
-                <a:spcPct val="105000"/>
-              </a:lnSpc>
-              <a:spcAft>
-                <a:spcPts val="900"/>
-              </a:spcAft>
-            </a:pPr>
-            <a:r>
-              <a:rPr sz="1400" b="1" i="0">
-                <a:solidFill>
-                  <a:srgbClr val="132190"/>
-                </a:solidFill>
-                <a:latin typeface="Arial"/>
-              </a:rPr>
-              <a:t>Digraph  </a:t>
-            </a:r>
-            <a:r>
-              <a:rPr sz="1400" b="0" i="0">
-                <a:solidFill>
-                  <a:srgbClr val="1A1A1A"/>
-                </a:solidFill>
-                <a:latin typeface="Arial"/>
-              </a:rPr>
-              <a:t>listas de adjacência (Bag) e reverse() → Gᵀ</a:t>
-            </a:r>
-          </a:p>
-          <a:p>
-            <a:pPr algn="l">
-              <a:lnSpc>
-                <a:spcPct val="105000"/>
-              </a:lnSpc>
-              <a:spcAft>
-                <a:spcPts val="900"/>
-              </a:spcAft>
-            </a:pPr>
-            <a:r>
-              <a:rPr sz="1400" b="1" i="0">
-                <a:solidFill>
-                  <a:srgbClr val="132190"/>
-                </a:solidFill>
-                <a:latin typeface="Arial"/>
-              </a:rPr>
-              <a:t>Stack  </a:t>
-            </a:r>
-            <a:r>
-              <a:rPr sz="1400" b="0" i="0">
-                <a:solidFill>
-                  <a:srgbClr val="1A1A1A"/>
-                </a:solidFill>
-                <a:latin typeface="Arial"/>
-              </a:rPr>
-              <a:t>guarda a pós-ordem reversa</a:t>
-            </a:r>
-          </a:p>
-          <a:p>
-            <a:pPr algn="l">
-              <a:lnSpc>
-                <a:spcPct val="105000"/>
-              </a:lnSpc>
-              <a:spcAft>
-                <a:spcPts val="900"/>
-              </a:spcAft>
-            </a:pPr>
-            <a:r>
-              <a:rPr sz="1400" b="1" i="0">
-                <a:solidFill>
-                  <a:srgbClr val="132190"/>
-                </a:solidFill>
-                <a:latin typeface="Arial"/>
-              </a:rPr>
-              <a:t>marked[ ], id[ ]  </a:t>
-            </a:r>
-            <a:r>
-              <a:rPr sz="1400" b="0" i="0">
-                <a:solidFill>
-                  <a:srgbClr val="1A1A1A"/>
-                </a:solidFill>
-                <a:latin typeface="Arial"/>
-              </a:rPr>
-              <a:t>visitado e componente</a:t>
-            </a:r>
-          </a:p>
-          <a:p>
-            <a:pPr algn="l">
-              <a:lnSpc>
-                <a:spcPct val="105000"/>
-              </a:lnSpc>
-              <a:spcAft>
-                <a:spcPts val="900"/>
-              </a:spcAft>
-            </a:pPr>
-            <a:r>
-              <a:rPr sz="1400" b="1" i="0">
-                <a:solidFill>
-                  <a:srgbClr val="132190"/>
-                </a:solidFill>
-                <a:latin typeface="Arial"/>
-              </a:rPr>
-              <a:t>O(V + E)  </a:t>
-            </a:r>
-            <a:r>
-              <a:rPr sz="1400" b="0" i="0">
-                <a:solidFill>
-                  <a:srgbClr val="1A1A1A"/>
-                </a:solidFill>
-                <a:latin typeface="Arial"/>
-              </a:rPr>
-              <a:t>duas DFS + construção de Gᵀ</a:t>
-            </a:r>
-          </a:p>
-        </p:txBody>
-      </p:sp>
-      <p:sp>
-        <p:nvSpPr>
-          <p:cNvPr id="4" name="Codigo"/>
+          <p:cNvPr id="3" name="Codigo"/>
           <p:cNvSpPr/>
           <p:nvPr/>
         </p:nvSpPr>
         <p:spPr>
           <a:xfrm>
-            <a:off x="4480560" y="1417320"/>
-            <a:ext cx="3977639" cy="2011680"/>
+            <a:off x="731520" y="1325880"/>
+            <a:ext cx="5074920" cy="3017520"/>
           </a:xfrm>
           <a:prstGeom prst="roundRect">
             <a:avLst>
@@ -12259,13 +12183,13 @@
               </a:lnSpc>
             </a:pPr>
             <a:r>
-              <a:rPr sz="1050" b="0" i="0">
-                <a:solidFill>
-                  <a:srgbClr val="5B6478"/>
+              <a:rPr sz="1000" b="0" i="0">
+                <a:solidFill>
+                  <a:srgbClr val="1A1A1A"/>
                 </a:solidFill>
                 <a:latin typeface="Consolas"/>
               </a:rPr>
-              <a:t>// fase 1: ordem topológica de Gᵀ</a:t>
+              <a:t>public KosarajuSharirSCC(Digraph digraph) {</a:t>
             </a:r>
           </a:p>
           <a:p>
@@ -12275,13 +12199,13 @@
               </a:lnSpc>
             </a:pPr>
             <a:r>
-              <a:rPr sz="1050" b="0" i="0">
-                <a:solidFill>
-                  <a:srgbClr val="1A1A1A"/>
+              <a:rPr sz="1000" b="0" i="0">
+                <a:solidFill>
+                  <a:srgbClr val="5B6478"/>
                 </a:solidFill>
                 <a:latin typeface="Consolas"/>
               </a:rPr>
-              <a:t>DepthFirstOrder ordem =</a:t>
+              <a:t>    // fase 1: pós-ordem reversa de Gᵀ</a:t>
             </a:r>
           </a:p>
           <a:p>
@@ -12291,13 +12215,13 @@
               </a:lnSpc>
             </a:pPr>
             <a:r>
-              <a:rPr sz="1050" b="0" i="0">
-                <a:solidFill>
-                  <a:srgbClr val="1A1A1A"/>
+              <a:rPr sz="1000" b="1" i="0">
+                <a:solidFill>
+                  <a:srgbClr val="004AF7"/>
                 </a:solidFill>
                 <a:latin typeface="Consolas"/>
               </a:rPr>
-              <a:t>    new DepthFirstOrder(G.reverse());</a:t>
+              <a:t>    DepthFirstOrder dfs = new DepthFirstOrder(digraph.reverse());</a:t>
             </a:r>
           </a:p>
           <a:p>
@@ -12306,21 +12230,14 @@
                 <a:spcPct val="102000"/>
               </a:lnSpc>
             </a:pPr>
-          </a:p>
-          <a:p>
-            <a:pPr algn="l">
-              <a:lnSpc>
-                <a:spcPct val="102000"/>
-              </a:lnSpc>
-            </a:pPr>
-            <a:r>
-              <a:rPr sz="1050" b="0" i="0">
+            <a:r>
+              <a:rPr sz="1000" b="0" i="0">
                 <a:solidFill>
                   <a:srgbClr val="5B6478"/>
                 </a:solidFill>
                 <a:latin typeface="Consolas"/>
               </a:rPr>
-              <a:t>// fase 2: DFS em G nessa ordem</a:t>
+              <a:t>    // fase 2: DFS em G seguindo essa ordem</a:t>
             </a:r>
           </a:p>
           <a:p>
@@ -12330,13 +12247,13 @@
               </a:lnSpc>
             </a:pPr>
             <a:r>
-              <a:rPr sz="1050" b="0" i="0">
-                <a:solidFill>
-                  <a:srgbClr val="1A1A1A"/>
+              <a:rPr sz="1000" b="1" i="0">
+                <a:solidFill>
+                  <a:srgbClr val="004AF7"/>
                 </a:solidFill>
                 <a:latin typeface="Consolas"/>
               </a:rPr>
-              <a:t>for (int v : ordem.reversePost())</a:t>
+              <a:t>    for (int v : dfs.reversePost()) {</a:t>
             </a:r>
           </a:p>
           <a:p>
@@ -12346,13 +12263,13 @@
               </a:lnSpc>
             </a:pPr>
             <a:r>
-              <a:rPr sz="1050" b="0" i="0">
-                <a:solidFill>
-                  <a:srgbClr val="1A1A1A"/>
+              <a:rPr sz="1000" b="1" i="0">
+                <a:solidFill>
+                  <a:srgbClr val="004AF7"/>
                 </a:solidFill>
                 <a:latin typeface="Consolas"/>
               </a:rPr>
-              <a:t>    if (!marked[v]) {</a:t>
+              <a:t>        if (!marked[v]) {</a:t>
             </a:r>
           </a:p>
           <a:p>
@@ -12362,13 +12279,13 @@
               </a:lnSpc>
             </a:pPr>
             <a:r>
-              <a:rPr sz="1050" b="1" i="0">
+              <a:rPr sz="1000" b="1" i="0">
                 <a:solidFill>
                   <a:srgbClr val="004AF7"/>
                 </a:solidFill>
                 <a:latin typeface="Consolas"/>
               </a:rPr>
-              <a:t>        dfs(G, v);   // id[w] = count</a:t>
+              <a:t>            dfs(digraph, v);</a:t>
             </a:r>
           </a:p>
           <a:p>
@@ -12378,13 +12295,13 @@
               </a:lnSpc>
             </a:pPr>
             <a:r>
-              <a:rPr sz="1050" b="1" i="0">
+              <a:rPr sz="1000" b="1" i="0">
                 <a:solidFill>
                   <a:srgbClr val="004AF7"/>
                 </a:solidFill>
                 <a:latin typeface="Consolas"/>
               </a:rPr>
-              <a:t>        count++;</a:t>
+              <a:t>            count++;</a:t>
             </a:r>
           </a:p>
           <a:p>
@@ -12394,42 +12311,172 @@
               </a:lnSpc>
             </a:pPr>
             <a:r>
-              <a:rPr sz="1050" b="0" i="0">
+              <a:rPr sz="1000" b="0" i="0">
+                <a:solidFill>
+                  <a:srgbClr val="1A1A1A"/>
+                </a:solidFill>
+                <a:latin typeface="Consolas"/>
+              </a:rPr>
+              <a:t>        }</a:t>
+            </a:r>
+          </a:p>
+          <a:p>
+            <a:pPr algn="l">
+              <a:lnSpc>
+                <a:spcPct val="102000"/>
+              </a:lnSpc>
+            </a:pPr>
+            <a:r>
+              <a:rPr sz="1000" b="0" i="0">
                 <a:solidFill>
                   <a:srgbClr val="1A1A1A"/>
                 </a:solidFill>
                 <a:latin typeface="Consolas"/>
               </a:rPr>
               <a:t>    }</a:t>
+            </a:r>
+          </a:p>
+          <a:p>
+            <a:pPr algn="l">
+              <a:lnSpc>
+                <a:spcPct val="102000"/>
+              </a:lnSpc>
+            </a:pPr>
+            <a:r>
+              <a:rPr sz="1000" b="0" i="0">
+                <a:solidFill>
+                  <a:srgbClr val="1A1A1A"/>
+                </a:solidFill>
+                <a:latin typeface="Consolas"/>
+              </a:rPr>
+              <a:t>}</a:t>
+            </a:r>
+          </a:p>
+          <a:p>
+            <a:pPr algn="l">
+              <a:lnSpc>
+                <a:spcPct val="102000"/>
+              </a:lnSpc>
+            </a:pPr>
+          </a:p>
+          <a:p>
+            <a:pPr algn="l">
+              <a:lnSpc>
+                <a:spcPct val="102000"/>
+              </a:lnSpc>
+            </a:pPr>
+            <a:r>
+              <a:rPr sz="1000" b="0" i="0">
+                <a:solidFill>
+                  <a:srgbClr val="1A1A1A"/>
+                </a:solidFill>
+                <a:latin typeface="Consolas"/>
+              </a:rPr>
+              <a:t>private void dfs(Digraph digraph, int v) {</a:t>
+            </a:r>
+          </a:p>
+          <a:p>
+            <a:pPr algn="l">
+              <a:lnSpc>
+                <a:spcPct val="102000"/>
+              </a:lnSpc>
+            </a:pPr>
+            <a:r>
+              <a:rPr sz="1000" b="1" i="0">
+                <a:solidFill>
+                  <a:srgbClr val="D9480F"/>
+                </a:solidFill>
+                <a:latin typeface="Consolas"/>
+              </a:rPr>
+              <a:t>    marked[v] = true;</a:t>
+            </a:r>
+          </a:p>
+          <a:p>
+            <a:pPr algn="l">
+              <a:lnSpc>
+                <a:spcPct val="102000"/>
+              </a:lnSpc>
+            </a:pPr>
+            <a:r>
+              <a:rPr sz="1000" b="1" i="0">
+                <a:solidFill>
+                  <a:srgbClr val="D9480F"/>
+                </a:solidFill>
+                <a:latin typeface="Consolas"/>
+              </a:rPr>
+              <a:t>    id[v] = count;</a:t>
+            </a:r>
+          </a:p>
+          <a:p>
+            <a:pPr algn="l">
+              <a:lnSpc>
+                <a:spcPct val="102000"/>
+              </a:lnSpc>
+            </a:pPr>
+            <a:r>
+              <a:rPr sz="1000" b="0" i="0">
+                <a:solidFill>
+                  <a:srgbClr val="1A1A1A"/>
+                </a:solidFill>
+                <a:latin typeface="Consolas"/>
+              </a:rPr>
+              <a:t>    for (int w : digraph.adj(v))</a:t>
+            </a:r>
+          </a:p>
+          <a:p>
+            <a:pPr algn="l">
+              <a:lnSpc>
+                <a:spcPct val="102000"/>
+              </a:lnSpc>
+            </a:pPr>
+            <a:r>
+              <a:rPr sz="1000" b="1" i="0">
+                <a:solidFill>
+                  <a:srgbClr val="D9480F"/>
+                </a:solidFill>
+                <a:latin typeface="Consolas"/>
+              </a:rPr>
+              <a:t>        if (!marked[w]) dfs(digraph, w);</a:t>
+            </a:r>
+          </a:p>
+          <a:p>
+            <a:pPr algn="l">
+              <a:lnSpc>
+                <a:spcPct val="102000"/>
+              </a:lnSpc>
+            </a:pPr>
+            <a:r>
+              <a:rPr sz="1000" b="0" i="0">
+                <a:solidFill>
+                  <a:srgbClr val="1A1A1A"/>
+                </a:solidFill>
+                <a:latin typeface="Consolas"/>
+              </a:rPr>
+              <a:t>}</a:t>
             </a:r>
           </a:p>
         </p:txBody>
       </p:sp>
       <p:sp>
         <p:nvSpPr>
-          <p:cNvPr id="5" name="Card"/>
+          <p:cNvPr id="4" name="Passo 1"/>
           <p:cNvSpPr/>
           <p:nvPr/>
         </p:nvSpPr>
         <p:spPr>
           <a:xfrm>
-            <a:off x="4480560" y="3566160"/>
-            <a:ext cx="3291840" cy="868680"/>
-          </a:xfrm>
-          <a:prstGeom prst="roundRect">
-            <a:avLst>
-              <a:gd name="adj" fmla="val 4000"/>
-            </a:avLst>
+            <a:off x="6035040" y="1508760"/>
+            <a:ext cx="274320" cy="274320"/>
+          </a:xfrm>
+          <a:prstGeom prst="ellipse">
+            <a:avLst/>
           </a:prstGeom>
           <a:solidFill>
-            <a:srgbClr val="FFFFFF"/>
+            <a:srgbClr val="004AF7"/>
           </a:solidFill>
-          <a:ln w="12700">
-            <a:solidFill>
-              <a:srgbClr val="B9D5FB"/>
-            </a:solidFill>
+          <a:ln>
+            <a:noFill/>
           </a:ln>
-          <a:effectLst/>
         </p:spPr>
         <p:style>
           <a:lnRef idx="1">
@@ -12438,7 +12485,7 @@
           <a:fillRef idx="3">
             <a:schemeClr val="accent1"/>
           </a:fillRef>
-          <a:effectRef idx="2">
+          <a:effectRef idx="0">
             <a:schemeClr val="accent1"/>
           </a:effectRef>
           <a:fontRef idx="minor">
@@ -12446,21 +12493,32 @@
           </a:fontRef>
         </p:style>
         <p:txBody>
-          <a:bodyPr rtlCol="0" anchor="ctr"/>
+          <a:bodyPr rtlCol="0" anchor="ctr" lIns="0" rIns="0" tIns="0" bIns="0"/>
           <a:lstStyle/>
-          <a:p/>
+          <a:p>
+            <a:pPr algn="ctr"/>
+            <a:r>
+              <a:rPr sz="1100" b="1" i="0">
+                <a:solidFill>
+                  <a:srgbClr val="FFFFFF"/>
+                </a:solidFill>
+                <a:latin typeface="Arial"/>
+              </a:rPr>
+              <a:t>1</a:t>
+            </a:r>
+          </a:p>
         </p:txBody>
       </p:sp>
       <p:sp>
         <p:nvSpPr>
-          <p:cNvPr id="6" name="TextBox 5"/>
+          <p:cNvPr id="5" name="TextBox 4"/>
           <p:cNvSpPr txBox="1"/>
           <p:nvPr/>
         </p:nvSpPr>
         <p:spPr>
           <a:xfrm>
-            <a:off x="4617720" y="3639312"/>
-            <a:ext cx="3063240" cy="731520"/>
+            <a:off x="6446520" y="1490472"/>
+            <a:ext cx="2011680" cy="731520"/>
           </a:xfrm>
           <a:prstGeom prst="rect">
             <a:avLst/>
@@ -12478,17 +12536,243 @@
                 <a:spcPct val="105000"/>
               </a:lnSpc>
               <a:spcAft>
-                <a:spcPts val="200"/>
+                <a:spcPts val="100"/>
               </a:spcAft>
             </a:pPr>
             <a:r>
+              <a:rPr sz="1300" b="1" i="0">
+                <a:solidFill>
+                  <a:srgbClr val="004AF7"/>
+                </a:solidFill>
+                <a:latin typeface="Arial"/>
+              </a:rPr>
+              <a:t>Fase 1</a:t>
+            </a:r>
+          </a:p>
+          <a:p>
+            <a:pPr algn="l">
+              <a:lnSpc>
+                <a:spcPct val="105000"/>
+              </a:lnSpc>
+              <a:spcAft>
+                <a:spcPts val="100"/>
+              </a:spcAft>
+            </a:pPr>
+            <a:r>
+              <a:rPr sz="1100" b="0" i="0">
+                <a:solidFill>
+                  <a:srgbClr val="1A1A1A"/>
+                </a:solidFill>
+                <a:latin typeface="Arial"/>
+              </a:rPr>
+              <a:t>ordem topológica de Gᵀ: sumidouros de G primeiro</a:t>
+            </a:r>
+          </a:p>
+        </p:txBody>
+      </p:sp>
+      <p:sp>
+        <p:nvSpPr>
+          <p:cNvPr id="6" name="Passo 2"/>
+          <p:cNvSpPr/>
+          <p:nvPr/>
+        </p:nvSpPr>
+        <p:spPr>
+          <a:xfrm>
+            <a:off x="6035040" y="2194560"/>
+            <a:ext cx="274320" cy="274320"/>
+          </a:xfrm>
+          <a:prstGeom prst="ellipse">
+            <a:avLst/>
+          </a:prstGeom>
+          <a:solidFill>
+            <a:srgbClr val="004AF7"/>
+          </a:solidFill>
+          <a:ln>
+            <a:noFill/>
+          </a:ln>
+        </p:spPr>
+        <p:style>
+          <a:lnRef idx="1">
+            <a:schemeClr val="accent1"/>
+          </a:lnRef>
+          <a:fillRef idx="3">
+            <a:schemeClr val="accent1"/>
+          </a:fillRef>
+          <a:effectRef idx="0">
+            <a:schemeClr val="accent1"/>
+          </a:effectRef>
+          <a:fontRef idx="minor">
+            <a:schemeClr val="lt1"/>
+          </a:fontRef>
+        </p:style>
+        <p:txBody>
+          <a:bodyPr rtlCol="0" anchor="ctr" lIns="0" rIns="0" tIns="0" bIns="0"/>
+          <a:lstStyle/>
+          <a:p>
+            <a:pPr algn="ctr"/>
+            <a:r>
               <a:rPr sz="1100" b="1" i="0">
                 <a:solidFill>
+                  <a:srgbClr val="FFFFFF"/>
+                </a:solidFill>
+                <a:latin typeface="Arial"/>
+              </a:rPr>
+              <a:t>2</a:t>
+            </a:r>
+          </a:p>
+        </p:txBody>
+      </p:sp>
+      <p:sp>
+        <p:nvSpPr>
+          <p:cNvPr id="7" name="TextBox 6"/>
+          <p:cNvSpPr txBox="1"/>
+          <p:nvPr/>
+        </p:nvSpPr>
+        <p:spPr>
+          <a:xfrm>
+            <a:off x="6446520" y="2176272"/>
+            <a:ext cx="2011680" cy="731520"/>
+          </a:xfrm>
+          <a:prstGeom prst="rect">
+            <a:avLst/>
+          </a:prstGeom>
+          <a:noFill/>
+        </p:spPr>
+        <p:txBody>
+          <a:bodyPr wrap="square" lIns="0" rIns="0" tIns="0" bIns="0" anchor="t">
+            <a:spAutoFit/>
+          </a:bodyPr>
+          <a:lstStyle/>
+          <a:p>
+            <a:pPr algn="l">
+              <a:lnSpc>
+                <a:spcPct val="105000"/>
+              </a:lnSpc>
+              <a:spcAft>
+                <a:spcPts val="100"/>
+              </a:spcAft>
+            </a:pPr>
+            <a:r>
+              <a:rPr sz="1300" b="1" i="0">
+                <a:solidFill>
+                  <a:srgbClr val="004AF7"/>
+                </a:solidFill>
+                <a:latin typeface="Arial"/>
+              </a:rPr>
+              <a:t>Fase 2</a:t>
+            </a:r>
+          </a:p>
+          <a:p>
+            <a:pPr algn="l">
+              <a:lnSpc>
+                <a:spcPct val="105000"/>
+              </a:lnSpc>
+              <a:spcAft>
+                <a:spcPts val="100"/>
+              </a:spcAft>
+            </a:pPr>
+            <a:r>
+              <a:rPr sz="1100" b="0" i="0">
+                <a:solidFill>
+                  <a:srgbClr val="1A1A1A"/>
+                </a:solidFill>
+                <a:latin typeface="Arial"/>
+              </a:rPr>
+              <a:t>cada DFS disparada aqui = uma componente (count++)</a:t>
+            </a:r>
+          </a:p>
+        </p:txBody>
+      </p:sp>
+      <p:sp>
+        <p:nvSpPr>
+          <p:cNvPr id="8" name="Passo 3"/>
+          <p:cNvSpPr/>
+          <p:nvPr/>
+        </p:nvSpPr>
+        <p:spPr>
+          <a:xfrm>
+            <a:off x="6035040" y="3383280"/>
+            <a:ext cx="274320" cy="274320"/>
+          </a:xfrm>
+          <a:prstGeom prst="ellipse">
+            <a:avLst/>
+          </a:prstGeom>
+          <a:solidFill>
+            <a:srgbClr val="D9480F"/>
+          </a:solidFill>
+          <a:ln>
+            <a:noFill/>
+          </a:ln>
+        </p:spPr>
+        <p:style>
+          <a:lnRef idx="1">
+            <a:schemeClr val="accent1"/>
+          </a:lnRef>
+          <a:fillRef idx="3">
+            <a:schemeClr val="accent1"/>
+          </a:fillRef>
+          <a:effectRef idx="0">
+            <a:schemeClr val="accent1"/>
+          </a:effectRef>
+          <a:fontRef idx="minor">
+            <a:schemeClr val="lt1"/>
+          </a:fontRef>
+        </p:style>
+        <p:txBody>
+          <a:bodyPr rtlCol="0" anchor="ctr" lIns="0" rIns="0" tIns="0" bIns="0"/>
+          <a:lstStyle/>
+          <a:p>
+            <a:pPr algn="ctr"/>
+            <a:r>
+              <a:rPr sz="1100" b="1" i="0">
+                <a:solidFill>
+                  <a:srgbClr val="FFFFFF"/>
+                </a:solidFill>
+                <a:latin typeface="Arial"/>
+              </a:rPr>
+              <a:t>3</a:t>
+            </a:r>
+          </a:p>
+        </p:txBody>
+      </p:sp>
+      <p:sp>
+        <p:nvSpPr>
+          <p:cNvPr id="9" name="TextBox 8"/>
+          <p:cNvSpPr txBox="1"/>
+          <p:nvPr/>
+        </p:nvSpPr>
+        <p:spPr>
+          <a:xfrm>
+            <a:off x="6446520" y="3364992"/>
+            <a:ext cx="2011680" cy="731520"/>
+          </a:xfrm>
+          <a:prstGeom prst="rect">
+            <a:avLst/>
+          </a:prstGeom>
+          <a:noFill/>
+        </p:spPr>
+        <p:txBody>
+          <a:bodyPr wrap="square" lIns="0" rIns="0" tIns="0" bIns="0" anchor="t">
+            <a:spAutoFit/>
+          </a:bodyPr>
+          <a:lstStyle/>
+          <a:p>
+            <a:pPr algn="l">
+              <a:lnSpc>
+                <a:spcPct val="105000"/>
+              </a:lnSpc>
+              <a:spcAft>
+                <a:spcPts val="100"/>
+              </a:spcAft>
+            </a:pPr>
+            <a:r>
+              <a:rPr sz="1300" b="1" i="0">
+                <a:solidFill>
                   <a:srgbClr val="D9480F"/>
                 </a:solidFill>
                 <a:latin typeface="Arial"/>
               </a:rPr>
-              <a:t>Recursão de até 100.000 níveis</a:t>
+              <a:t>dfs</a:t>
             </a:r>
           </a:p>
           <a:p>
@@ -12497,7 +12781,7 @@
                 <a:spcPct val="105000"/>
               </a:lnSpc>
               <a:spcAft>
-                <a:spcPts val="200"/>
+                <a:spcPts val="100"/>
               </a:spcAft>
             </a:pPr>
             <a:r>
@@ -12507,7 +12791,7 @@
                 </a:solidFill>
                 <a:latin typeface="Arial"/>
               </a:rPr>
-              <a:t>BFS não serve: não tem pós-ordem. DFS mantida, numa Thread com 256 MB de pilha.</a:t>
+              <a:t>grava id[v] e não entra em quem já foi marcado: não vaza</a:t>
             </a:r>
           </a:p>
         </p:txBody>
@@ -12562,7 +12846,7 @@
                 </a:solidFill>
                 <a:latin typeface="Arial"/>
               </a:rPr>
-              <a:t>Validação e resultados</a:t>
+              <a:t>Estruturas e custo</a:t>
             </a:r>
           </a:p>
           <a:p>
@@ -12574,7 +12858,7 @@
                 </a:solidFill>
                 <a:latin typeface="Arial"/>
               </a:rPr>
-              <a:t>Testes, complexidade e submissão</a:t>
+              <a:t>O que o código usa (algs4)</a:t>
             </a:r>
           </a:p>
         </p:txBody>
@@ -12588,7 +12872,7 @@
         <p:spPr>
           <a:xfrm>
             <a:off x="731520" y="1554480"/>
-            <a:ext cx="3429000" cy="2651760"/>
+            <a:ext cx="3566160" cy="2743200"/>
           </a:xfrm>
           <a:prstGeom prst="rect">
             <a:avLst/>
@@ -12610,13 +12894,22 @@
               </a:spcAft>
             </a:pPr>
             <a:r>
+              <a:rPr sz="1400" b="1" i="0">
+                <a:solidFill>
+                  <a:srgbClr val="132190"/>
+                </a:solidFill>
+                <a:latin typeface="Arial"/>
+              </a:rPr>
+              <a:t>Digraph  </a:t>
+            </a:r>
+            <a:r>
               <a:rPr sz="1400" b="0" i="0">
                 <a:solidFill>
                   <a:srgbClr val="1A1A1A"/>
                 </a:solidFill>
                 <a:latin typeface="Arial"/>
               </a:rPr>
-              <a:t>8 casos pequenos + 5 de estresse: todos corretos</a:t>
+              <a:t>listas de adjacência (Bag) e reverse() → Gᵀ</a:t>
             </a:r>
           </a:p>
           <a:p>
@@ -12629,13 +12922,22 @@
               </a:spcAft>
             </a:pPr>
             <a:r>
+              <a:rPr sz="1400" b="1" i="0">
+                <a:solidFill>
+                  <a:srgbClr val="132190"/>
+                </a:solidFill>
+                <a:latin typeface="Arial"/>
+              </a:rPr>
+              <a:t>Stack  </a:t>
+            </a:r>
+            <a:r>
               <a:rPr sz="1400" b="0" i="0">
                 <a:solidFill>
                   <a:srgbClr val="1A1A1A"/>
                 </a:solidFill>
                 <a:latin typeface="Arial"/>
               </a:rPr>
-              <a:t>Cada NO conferido por BFS de a até b</a:t>
+              <a:t>guarda a pós-ordem reversa</a:t>
             </a:r>
           </a:p>
           <a:p>
@@ -12648,13 +12950,22 @@
               </a:spcAft>
             </a:pPr>
             <a:r>
+              <a:rPr sz="1400" b="1" i="0">
+                <a:solidFill>
+                  <a:srgbClr val="132190"/>
+                </a:solidFill>
+                <a:latin typeface="Arial"/>
+              </a:rPr>
+              <a:t>marked[ ], id[ ]  </a:t>
+            </a:r>
+            <a:r>
               <a:rPr sz="1400" b="0" i="0">
                 <a:solidFill>
                   <a:srgbClr val="1A1A1A"/>
                 </a:solidFill>
                 <a:latin typeface="Arial"/>
               </a:rPr>
-              <a:t>Ciclos ligados num só sentido: NO (sem direção daria YES)</a:t>
+              <a:t>visitado e componente</a:t>
             </a:r>
           </a:p>
           <a:p>
@@ -12673,7 +12984,16 @@
                 </a:solidFill>
                 <a:latin typeface="Arial"/>
               </a:rPr>
-              <a:t>ACCEPTED no CSES — 20/20 testes, pior 0,97 s</a:t>
+              <a:t>O(V + E)  </a:t>
+            </a:r>
+            <a:r>
+              <a:rPr sz="1400" b="0" i="0">
+                <a:solidFill>
+                  <a:srgbClr val="1A1A1A"/>
+                </a:solidFill>
+                <a:latin typeface="Arial"/>
+              </a:rPr>
+              <a:t>duas DFS + construção de Gᵀ</a:t>
             </a:r>
           </a:p>
         </p:txBody>
@@ -12686,8 +13006,8 @@
         </p:nvSpPr>
         <p:spPr>
           <a:xfrm>
-            <a:off x="4343400" y="1554480"/>
-            <a:ext cx="4114800" cy="2011680"/>
+            <a:off x="4480560" y="1417320"/>
+            <a:ext cx="3977639" cy="2011680"/>
           </a:xfrm>
           <a:prstGeom prst="roundRect">
             <a:avLst>
@@ -12734,8 +13054,15 @@
                 </a:solidFill>
                 <a:latin typeface="Consolas"/>
               </a:rPr>
-              <a:t>caso                 esper.  obtido</a:t>
-            </a:r>
+              <a:t>G (listas)        Gᵀ = G.reverse()</a:t>
+            </a:r>
+          </a:p>
+          <a:p>
+            <a:pPr algn="l">
+              <a:lnSpc>
+                <a:spcPct val="102000"/>
+              </a:lnSpc>
+            </a:pPr>
           </a:p>
           <a:p>
             <a:pPr algn="l">
@@ -12750,7 +13077,7 @@
                 </a:solidFill>
                 <a:latin typeface="Consolas"/>
               </a:rPr>
-              <a:t>exemplo oficial        NO     NO 4 1</a:t>
+              <a:t>1: 4, 2           1: 3</a:t>
             </a:r>
           </a:p>
           <a:p>
@@ -12766,7 +13093,7 @@
                 </a:solidFill>
                 <a:latin typeface="Consolas"/>
               </a:rPr>
-              <a:t>ciclo único            YES    YES</a:t>
+              <a:t>2: 3              2: 1</a:t>
             </a:r>
           </a:p>
           <a:p>
@@ -12782,7 +13109,7 @@
                 </a:solidFill>
                 <a:latin typeface="Consolas"/>
               </a:rPr>
-              <a:t>cidade com laço        YES    YES</a:t>
+              <a:t>3: 4, 1           3: 2</a:t>
             </a:r>
           </a:p>
           <a:p>
@@ -12798,7 +13125,7 @@
                 </a:solidFill>
                 <a:latin typeface="Consolas"/>
               </a:rPr>
-              <a:t>caminho 1→2→3          NO     NO 3 1</a:t>
+              <a:t>4: –              4: 3, 1</a:t>
             </a:r>
           </a:p>
           <a:p>
@@ -12807,14 +13134,21 @@
                 <a:spcPct val="102000"/>
               </a:lnSpc>
             </a:pPr>
+          </a:p>
+          <a:p>
+            <a:pPr algn="l">
+              <a:lnSpc>
+                <a:spcPct val="102000"/>
+              </a:lnSpc>
+            </a:pPr>
             <a:r>
               <a:rPr sz="1050" b="0" i="0">
                 <a:solidFill>
-                  <a:srgbClr val="1A1A1A"/>
+                  <a:srgbClr val="5B6478"/>
                 </a:solidFill>
                 <a:latin typeface="Consolas"/>
               </a:rPr>
-              <a:t>ciclos, 1 sentido      NO     NO 3 1</a:t>
+              <a:t>cada aresta a → b vira b → a</a:t>
             </a:r>
           </a:p>
           <a:p>
@@ -12826,43 +13160,118 @@
             <a:r>
               <a:rPr sz="1050" b="0" i="0">
                 <a:solidFill>
-                  <a:srgbClr val="1A1A1A"/>
+                  <a:srgbClr val="5B6478"/>
                 </a:solidFill>
                 <a:latin typeface="Consolas"/>
               </a:rPr>
-              <a:t>cidade isolada         NO     NO 3 1</a:t>
-            </a:r>
-          </a:p>
+              <a:t>O(V + E) para construir</a:t>
+            </a:r>
+          </a:p>
+        </p:txBody>
+      </p:sp>
+      <p:sp>
+        <p:nvSpPr>
+          <p:cNvPr id="5" name="Card"/>
+          <p:cNvSpPr/>
+          <p:nvPr/>
+        </p:nvSpPr>
+        <p:spPr>
+          <a:xfrm>
+            <a:off x="4480560" y="3566160"/>
+            <a:ext cx="3291840" cy="868680"/>
+          </a:xfrm>
+          <a:prstGeom prst="roundRect">
+            <a:avLst>
+              <a:gd name="adj" fmla="val 4000"/>
+            </a:avLst>
+          </a:prstGeom>
+          <a:solidFill>
+            <a:srgbClr val="FFFFFF"/>
+          </a:solidFill>
+          <a:ln w="12700">
+            <a:solidFill>
+              <a:srgbClr val="B9D5FB"/>
+            </a:solidFill>
+          </a:ln>
+          <a:effectLst/>
+        </p:spPr>
+        <p:style>
+          <a:lnRef idx="1">
+            <a:schemeClr val="accent1"/>
+          </a:lnRef>
+          <a:fillRef idx="3">
+            <a:schemeClr val="accent1"/>
+          </a:fillRef>
+          <a:effectRef idx="2">
+            <a:schemeClr val="accent1"/>
+          </a:effectRef>
+          <a:fontRef idx="minor">
+            <a:schemeClr val="lt1"/>
+          </a:fontRef>
+        </p:style>
+        <p:txBody>
+          <a:bodyPr rtlCol="0" anchor="ctr"/>
+          <a:lstStyle/>
+          <a:p/>
+        </p:txBody>
+      </p:sp>
+      <p:sp>
+        <p:nvSpPr>
+          <p:cNvPr id="6" name="TextBox 5"/>
+          <p:cNvSpPr txBox="1"/>
+          <p:nvPr/>
+        </p:nvSpPr>
+        <p:spPr>
+          <a:xfrm>
+            <a:off x="4617720" y="3639312"/>
+            <a:ext cx="3063240" cy="731520"/>
+          </a:xfrm>
+          <a:prstGeom prst="rect">
+            <a:avLst/>
+          </a:prstGeom>
+          <a:noFill/>
+        </p:spPr>
+        <p:txBody>
+          <a:bodyPr wrap="square" lIns="0" rIns="0" tIns="0" bIns="0" anchor="t">
+            <a:spAutoFit/>
+          </a:bodyPr>
+          <a:lstStyle/>
           <a:p>
             <a:pPr algn="l">
               <a:lnSpc>
-                <a:spcPct val="102000"/>
-              </a:lnSpc>
+                <a:spcPct val="105000"/>
+              </a:lnSpc>
+              <a:spcAft>
+                <a:spcPts val="200"/>
+              </a:spcAft>
             </a:pPr>
             <a:r>
-              <a:rPr sz="1050" b="0" i="0">
+              <a:rPr sz="1100" b="1" i="0">
+                <a:solidFill>
+                  <a:srgbClr val="D9480F"/>
+                </a:solidFill>
+                <a:latin typeface="Arial"/>
+              </a:rPr>
+              <a:t>Recursão de até 100.000 níveis</a:t>
+            </a:r>
+          </a:p>
+          <a:p>
+            <a:pPr algn="l">
+              <a:lnSpc>
+                <a:spcPct val="105000"/>
+              </a:lnSpc>
+              <a:spcAft>
+                <a:spcPts val="200"/>
+              </a:spcAft>
+            </a:pPr>
+            <a:r>
+              <a:rPr sz="1100" b="0" i="0">
                 <a:solidFill>
                   <a:srgbClr val="1A1A1A"/>
                 </a:solidFill>
-                <a:latin typeface="Consolas"/>
+                <a:latin typeface="Arial"/>
               </a:rPr>
-              <a:t>ciclo 100.000          YES    YES  0,22s</a:t>
-            </a:r>
-          </a:p>
-          <a:p>
-            <a:pPr algn="l">
-              <a:lnSpc>
-                <a:spcPct val="102000"/>
-              </a:lnSpc>
-            </a:pPr>
-            <a:r>
-              <a:rPr sz="1050" b="0" i="0">
-                <a:solidFill>
-                  <a:srgbClr val="1A1A1A"/>
-                </a:solidFill>
-                <a:latin typeface="Consolas"/>
-              </a:rPr>
-              <a:t>10⁵ V, 2·10⁵ E         NO     NO   0,27s</a:t>
+              <a:t>BFS não serve: não tem pós-ordem. DFS mantida, numa Thread com 256 MB de pilha.</a:t>
             </a:r>
           </a:p>
         </p:txBody>
@@ -12876,6 +13285,361 @@
 </file>
 
 <file path=ppt/slides/slide13.xml><?xml version="1.0" encoding="utf-8"?>
+<p:sld xmlns:a="http://schemas.openxmlformats.org/drawingml/2006/main" xmlns:p="http://schemas.openxmlformats.org/presentationml/2006/main" xmlns:r="http://schemas.openxmlformats.org/officeDocument/2006/relationships">
+  <p:cSld>
+    <p:spTree>
+      <p:nvGrpSpPr>
+        <p:cNvPr id="1" name=""/>
+        <p:cNvGrpSpPr/>
+        <p:nvPr/>
+      </p:nvGrpSpPr>
+      <p:grpSpPr/>
+      <p:sp>
+        <p:nvSpPr>
+          <p:cNvPr id="2" name="Title 1"/>
+          <p:cNvSpPr>
+            <a:spLocks noGrp="1"/>
+          </p:cNvSpPr>
+          <p:nvPr>
+            <p:ph type="title"/>
+          </p:nvPr>
+        </p:nvSpPr>
+        <p:spPr>
+          <a:xfrm>
+            <a:off x="749808" y="274320"/>
+            <a:ext cx="7818120" cy="1051560"/>
+          </a:xfrm>
+        </p:spPr>
+        <p:txBody>
+          <a:bodyPr/>
+          <a:lstStyle/>
+          <a:p>
+            <a:pPr algn="l">
+              <a:spcAft>
+                <a:spcPts val="200"/>
+              </a:spcAft>
+            </a:pPr>
+            <a:r>
+              <a:rPr sz="2850" b="1" i="0">
+                <a:solidFill>
+                  <a:srgbClr val="132190"/>
+                </a:solidFill>
+                <a:latin typeface="Arial"/>
+              </a:rPr>
+              <a:t>Validação e resultados</a:t>
+            </a:r>
+          </a:p>
+          <a:p>
+            <a:pPr algn="l"/>
+            <a:r>
+              <a:rPr sz="1500" b="0" i="0">
+                <a:solidFill>
+                  <a:srgbClr val="004AF7"/>
+                </a:solidFill>
+                <a:latin typeface="Arial"/>
+              </a:rPr>
+              <a:t>Testes, complexidade e submissão</a:t>
+            </a:r>
+          </a:p>
+        </p:txBody>
+      </p:sp>
+      <p:sp>
+        <p:nvSpPr>
+          <p:cNvPr id="3" name="Texto"/>
+          <p:cNvSpPr txBox="1"/>
+          <p:nvPr/>
+        </p:nvSpPr>
+        <p:spPr>
+          <a:xfrm>
+            <a:off x="731520" y="1554480"/>
+            <a:ext cx="3429000" cy="2651760"/>
+          </a:xfrm>
+          <a:prstGeom prst="rect">
+            <a:avLst/>
+          </a:prstGeom>
+          <a:noFill/>
+        </p:spPr>
+        <p:txBody>
+          <a:bodyPr wrap="square" lIns="0" rIns="0" tIns="0" bIns="0" anchor="t">
+            <a:spAutoFit/>
+          </a:bodyPr>
+          <a:lstStyle/>
+          <a:p>
+            <a:pPr algn="l">
+              <a:lnSpc>
+                <a:spcPct val="105000"/>
+              </a:lnSpc>
+              <a:spcAft>
+                <a:spcPts val="900"/>
+              </a:spcAft>
+            </a:pPr>
+            <a:r>
+              <a:rPr sz="1400" b="0" i="0">
+                <a:solidFill>
+                  <a:srgbClr val="1A1A1A"/>
+                </a:solidFill>
+                <a:latin typeface="Arial"/>
+              </a:rPr>
+              <a:t>8 casos pequenos + 5 de estresse: todos corretos</a:t>
+            </a:r>
+          </a:p>
+          <a:p>
+            <a:pPr algn="l">
+              <a:lnSpc>
+                <a:spcPct val="105000"/>
+              </a:lnSpc>
+              <a:spcAft>
+                <a:spcPts val="900"/>
+              </a:spcAft>
+            </a:pPr>
+            <a:r>
+              <a:rPr sz="1400" b="0" i="0">
+                <a:solidFill>
+                  <a:srgbClr val="1A1A1A"/>
+                </a:solidFill>
+                <a:latin typeface="Arial"/>
+              </a:rPr>
+              <a:t>Cada NO conferido por BFS de a até b</a:t>
+            </a:r>
+          </a:p>
+          <a:p>
+            <a:pPr algn="l">
+              <a:lnSpc>
+                <a:spcPct val="105000"/>
+              </a:lnSpc>
+              <a:spcAft>
+                <a:spcPts val="900"/>
+              </a:spcAft>
+            </a:pPr>
+            <a:r>
+              <a:rPr sz="1400" b="0" i="0">
+                <a:solidFill>
+                  <a:srgbClr val="1A1A1A"/>
+                </a:solidFill>
+                <a:latin typeface="Arial"/>
+              </a:rPr>
+              <a:t>Ciclos ligados num só sentido: NO (sem direção daria YES)</a:t>
+            </a:r>
+          </a:p>
+          <a:p>
+            <a:pPr algn="l">
+              <a:lnSpc>
+                <a:spcPct val="105000"/>
+              </a:lnSpc>
+              <a:spcAft>
+                <a:spcPts val="900"/>
+              </a:spcAft>
+            </a:pPr>
+            <a:r>
+              <a:rPr sz="1400" b="1" i="0">
+                <a:solidFill>
+                  <a:srgbClr val="132190"/>
+                </a:solidFill>
+                <a:latin typeface="Arial"/>
+              </a:rPr>
+              <a:t>ACCEPTED no CSES — 20/20 testes, pior 0,97 s</a:t>
+            </a:r>
+          </a:p>
+        </p:txBody>
+      </p:sp>
+      <p:sp>
+        <p:nvSpPr>
+          <p:cNvPr id="4" name="Codigo"/>
+          <p:cNvSpPr/>
+          <p:nvPr/>
+        </p:nvSpPr>
+        <p:spPr>
+          <a:xfrm>
+            <a:off x="4343400" y="1554480"/>
+            <a:ext cx="4114800" cy="2011680"/>
+          </a:xfrm>
+          <a:prstGeom prst="roundRect">
+            <a:avLst>
+              <a:gd name="adj" fmla="val 4000"/>
+            </a:avLst>
+          </a:prstGeom>
+          <a:solidFill>
+            <a:srgbClr val="FFFFFF"/>
+          </a:solidFill>
+          <a:ln w="12700">
+            <a:solidFill>
+              <a:srgbClr val="B9D5FB"/>
+            </a:solidFill>
+          </a:ln>
+          <a:effectLst/>
+        </p:spPr>
+        <p:style>
+          <a:lnRef idx="1">
+            <a:schemeClr val="accent1"/>
+          </a:lnRef>
+          <a:fillRef idx="3">
+            <a:schemeClr val="accent1"/>
+          </a:fillRef>
+          <a:effectRef idx="2">
+            <a:schemeClr val="accent1"/>
+          </a:effectRef>
+          <a:fontRef idx="minor">
+            <a:schemeClr val="lt1"/>
+          </a:fontRef>
+        </p:style>
+        <p:txBody>
+          <a:bodyPr rtlCol="0" anchor="t" wrap="none" lIns="128016" rIns="73152" tIns="91440" bIns="73152"/>
+          <a:lstStyle/>
+          <a:p>
+            <a:pPr algn="l">
+              <a:lnSpc>
+                <a:spcPct val="102000"/>
+              </a:lnSpc>
+            </a:pPr>
+            <a:r>
+              <a:rPr sz="1050" b="1" i="0">
+                <a:solidFill>
+                  <a:srgbClr val="004AF7"/>
+                </a:solidFill>
+                <a:latin typeface="Consolas"/>
+              </a:rPr>
+              <a:t>caso                 esper.  obtido</a:t>
+            </a:r>
+          </a:p>
+          <a:p>
+            <a:pPr algn="l">
+              <a:lnSpc>
+                <a:spcPct val="102000"/>
+              </a:lnSpc>
+            </a:pPr>
+            <a:r>
+              <a:rPr sz="1050" b="0" i="0">
+                <a:solidFill>
+                  <a:srgbClr val="1A1A1A"/>
+                </a:solidFill>
+                <a:latin typeface="Consolas"/>
+              </a:rPr>
+              <a:t>exemplo oficial        NO     NO 4 1</a:t>
+            </a:r>
+          </a:p>
+          <a:p>
+            <a:pPr algn="l">
+              <a:lnSpc>
+                <a:spcPct val="102000"/>
+              </a:lnSpc>
+            </a:pPr>
+            <a:r>
+              <a:rPr sz="1050" b="0" i="0">
+                <a:solidFill>
+                  <a:srgbClr val="1A1A1A"/>
+                </a:solidFill>
+                <a:latin typeface="Consolas"/>
+              </a:rPr>
+              <a:t>ciclo único            YES    YES</a:t>
+            </a:r>
+          </a:p>
+          <a:p>
+            <a:pPr algn="l">
+              <a:lnSpc>
+                <a:spcPct val="102000"/>
+              </a:lnSpc>
+            </a:pPr>
+            <a:r>
+              <a:rPr sz="1050" b="0" i="0">
+                <a:solidFill>
+                  <a:srgbClr val="1A1A1A"/>
+                </a:solidFill>
+                <a:latin typeface="Consolas"/>
+              </a:rPr>
+              <a:t>cidade com laço        YES    YES</a:t>
+            </a:r>
+          </a:p>
+          <a:p>
+            <a:pPr algn="l">
+              <a:lnSpc>
+                <a:spcPct val="102000"/>
+              </a:lnSpc>
+            </a:pPr>
+            <a:r>
+              <a:rPr sz="1050" b="0" i="0">
+                <a:solidFill>
+                  <a:srgbClr val="1A1A1A"/>
+                </a:solidFill>
+                <a:latin typeface="Consolas"/>
+              </a:rPr>
+              <a:t>caminho 1→2→3          NO     NO 3 1</a:t>
+            </a:r>
+          </a:p>
+          <a:p>
+            <a:pPr algn="l">
+              <a:lnSpc>
+                <a:spcPct val="102000"/>
+              </a:lnSpc>
+            </a:pPr>
+            <a:r>
+              <a:rPr sz="1050" b="0" i="0">
+                <a:solidFill>
+                  <a:srgbClr val="1A1A1A"/>
+                </a:solidFill>
+                <a:latin typeface="Consolas"/>
+              </a:rPr>
+              <a:t>ciclos, 1 sentido      NO     NO 3 1</a:t>
+            </a:r>
+          </a:p>
+          <a:p>
+            <a:pPr algn="l">
+              <a:lnSpc>
+                <a:spcPct val="102000"/>
+              </a:lnSpc>
+            </a:pPr>
+            <a:r>
+              <a:rPr sz="1050" b="0" i="0">
+                <a:solidFill>
+                  <a:srgbClr val="1A1A1A"/>
+                </a:solidFill>
+                <a:latin typeface="Consolas"/>
+              </a:rPr>
+              <a:t>cidade isolada         NO     NO 3 1</a:t>
+            </a:r>
+          </a:p>
+          <a:p>
+            <a:pPr algn="l">
+              <a:lnSpc>
+                <a:spcPct val="102000"/>
+              </a:lnSpc>
+            </a:pPr>
+            <a:r>
+              <a:rPr sz="1050" b="0" i="0">
+                <a:solidFill>
+                  <a:srgbClr val="1A1A1A"/>
+                </a:solidFill>
+                <a:latin typeface="Consolas"/>
+              </a:rPr>
+              <a:t>ciclo 100.000          YES    YES  0,22s</a:t>
+            </a:r>
+          </a:p>
+          <a:p>
+            <a:pPr algn="l">
+              <a:lnSpc>
+                <a:spcPct val="102000"/>
+              </a:lnSpc>
+            </a:pPr>
+            <a:r>
+              <a:rPr sz="1050" b="0" i="0">
+                <a:solidFill>
+                  <a:srgbClr val="1A1A1A"/>
+                </a:solidFill>
+                <a:latin typeface="Consolas"/>
+              </a:rPr>
+              <a:t>10⁵ V, 2·10⁵ E         NO     NO   0,27s</a:t>
+            </a:r>
+          </a:p>
+        </p:txBody>
+      </p:sp>
+    </p:spTree>
+  </p:cSld>
+  <p:clrMapOvr>
+    <a:masterClrMapping/>
+  </p:clrMapOvr>
+</p:sld>
+</file>
+
+<file path=ppt/slides/slide14.xml><?xml version="1.0" encoding="utf-8"?>
 <p:sld xmlns:a="http://schemas.openxmlformats.org/drawingml/2006/main" xmlns:r="http://schemas.openxmlformats.org/officeDocument/2006/relationships" xmlns:mc="http://schemas.openxmlformats.org/markup-compatibility/2006" xmlns:mv="urn:schemas-microsoft-com:mac:vml" xmlns:p="http://schemas.openxmlformats.org/presentationml/2006/main" xmlns:c="http://schemas.openxmlformats.org/drawingml/2006/chart" xmlns:dgm="http://schemas.openxmlformats.org/drawingml/2006/diagram" xmlns:o="urn:schemas-microsoft-com:office:office" xmlns:v="urn:schemas-microsoft-com:vml" xmlns:pvml="urn:schemas-microsoft-com:office:powerpoint" xmlns:com="http://schemas.openxmlformats.org/drawingml/2006/compatibility" xmlns:p14="http://schemas.microsoft.com/office/powerpoint/2010/main" xmlns:p15="http://schemas.microsoft.com/office/powerpoint/2012/main" xmlns:ahyp="http://schemas.microsoft.com/office/drawing/2018/hyperlinkcolor">
   <p:cSld>
     <p:spTree>

</xml_diff>